<commit_message>
Updates S5 Pruebas de hipotesis
</commit_message>
<xml_diff>
--- a/05-analisis-estadistico/11-integracion-sprint.pptx
+++ b/05-analisis-estadistico/11-integracion-sprint.pptx
@@ -102,7 +102,7 @@
                 <a:tab algn="l" pos="0"/>
               </a:tabLst>
             </a:pPr>
-            <a:fld id="{8770D5D7-B9F3-406C-9611-200844A637D4}" type="slidenum">
+            <a:fld id="{E615E848-4521-479E-BFD0-5C770CBC0D47}" type="slidenum">
               <a:rPr b="0" lang="en" sz="1000" strike="noStrike" u="none">
                 <a:solidFill>
                   <a:schemeClr val="dk2"/>
@@ -818,7 +818,7 @@
                 <a:tab algn="l" pos="0"/>
               </a:tabLst>
             </a:pPr>
-            <a:fld id="{0209DC55-3724-4DCA-ABA2-46468554840B}" type="slidenum">
+            <a:fld id="{C2257D3F-6FD0-4BDD-AA8A-717903429E8F}" type="slidenum">
               <a:rPr b="0" lang="en" sz="1000" strike="noStrike" u="none">
                 <a:solidFill>
                   <a:schemeClr val="dk2"/>
@@ -2082,7 +2082,7 @@
                 <a:tab algn="l" pos="0"/>
               </a:tabLst>
             </a:pPr>
-            <a:fld id="{6864924F-2FFA-49A8-9B90-18605EC3546B}" type="slidenum">
+            <a:fld id="{70D3F2AD-1345-48F3-B680-E058F47AD37F}" type="slidenum">
               <a:rPr b="0" lang="en" sz="1000" strike="noStrike" u="none">
                 <a:solidFill>
                   <a:schemeClr val="dk2"/>
@@ -3894,7 +3894,7 @@
                 <a:tab algn="l" pos="0"/>
               </a:tabLst>
             </a:pPr>
-            <a:fld id="{84291EFB-9BAB-45DF-9ADB-404CFF35B014}" type="slidenum">
+            <a:fld id="{118FFD24-AAEE-4152-9ED2-5235C7AA376F}" type="slidenum">
               <a:rPr b="0" lang="en" sz="1000" strike="noStrike" u="none">
                 <a:solidFill>
                   <a:schemeClr val="dk2"/>
@@ -4003,7 +4003,7 @@
                 <a:tab algn="l" pos="0"/>
               </a:tabLst>
             </a:pPr>
-            <a:fld id="{0F94FE44-E698-4444-8971-72476172DAED}" type="slidenum">
+            <a:fld id="{12923C8B-B5A9-4715-A4B6-06443DFF082D}" type="slidenum">
               <a:rPr b="0" lang="en" sz="1000" strike="noStrike" u="none">
                 <a:solidFill>
                   <a:schemeClr val="dk2"/>
@@ -4504,7 +4504,7 @@
                 <a:tab algn="l" pos="0"/>
               </a:tabLst>
             </a:pPr>
-            <a:fld id="{06488E17-589C-4CD3-A39B-F998FA25231D}" type="slidenum">
+            <a:fld id="{ED9786B0-2D17-4BC2-8129-6218F161CC9E}" type="slidenum">
               <a:rPr b="0" lang="en" sz="1000" strike="noStrike" u="none">
                 <a:solidFill>
                   <a:schemeClr val="dk2"/>
@@ -4946,7 +4946,7 @@
                 <a:tab algn="l" pos="0"/>
               </a:tabLst>
             </a:pPr>
-            <a:fld id="{F9FA2C0A-F868-4DFB-B9B9-1A86B5016195}" type="slidenum">
+            <a:fld id="{FF02852B-5BDD-45BE-A64B-CAB19777A2B8}" type="slidenum">
               <a:rPr b="0" lang="en" sz="1000" strike="noStrike" u="none">
                 <a:solidFill>
                   <a:schemeClr val="dk2"/>
@@ -5662,7 +5662,7 @@
                 <a:tab algn="l" pos="0"/>
               </a:tabLst>
             </a:pPr>
-            <a:fld id="{59005DA8-1AC0-4F69-AFDA-7D74A69AC9AD}" type="slidenum">
+            <a:fld id="{710248FD-203C-484F-82E6-4E129A8295F9}" type="slidenum">
               <a:rPr b="0" lang="en" sz="1000" strike="noStrike" u="none">
                 <a:solidFill>
                   <a:schemeClr val="dk2"/>
@@ -5830,7 +5830,7 @@
                 <a:tab algn="l" pos="0"/>
               </a:tabLst>
             </a:pPr>
-            <a:fld id="{34E2189A-5DCB-4ED6-90A9-7434EC450249}" type="slidenum">
+            <a:fld id="{E605CE0C-2B87-48A4-9A17-E3372E1B2444}" type="slidenum">
               <a:rPr b="0" lang="en" sz="1000" strike="noStrike" u="none">
                 <a:solidFill>
                   <a:schemeClr val="dk2"/>
@@ -5939,7 +5939,7 @@
                 <a:tab algn="l" pos="0"/>
               </a:tabLst>
             </a:pPr>
-            <a:fld id="{4B11DBF9-E776-4788-A755-F7C7669F91CA}" type="slidenum">
+            <a:fld id="{AFAF1629-DD82-4CBC-BD13-9E913CFD7EC3}" type="slidenum">
               <a:rPr b="0" lang="en" sz="1000" strike="noStrike" u="none">
                 <a:solidFill>
                   <a:schemeClr val="dk2"/>
@@ -6929,7 +6929,7 @@
                 <a:tab algn="l" pos="0"/>
               </a:tabLst>
             </a:pPr>
-            <a:fld id="{612D9EAB-3430-43D6-BB84-EB35A127249D}" type="slidenum">
+            <a:fld id="{E4374DEA-30DC-4C8F-BF0D-F93950010104}" type="slidenum">
               <a:rPr b="0" lang="en" sz="1000" strike="noStrike" u="none">
                 <a:solidFill>
                   <a:schemeClr val="dk2"/>
@@ -7097,7 +7097,7 @@
                 <a:tab algn="l" pos="0"/>
               </a:tabLst>
             </a:pPr>
-            <a:fld id="{BB5FBCC5-CE97-4FA9-9642-72DD0691E205}" type="slidenum">
+            <a:fld id="{DDFD8720-A468-400D-93E9-6C1BA41796A3}" type="slidenum">
               <a:rPr b="0" lang="en" sz="1000" strike="noStrike" u="none">
                 <a:solidFill>
                   <a:schemeClr val="dk2"/>
@@ -8087,7 +8087,7 @@
                 <a:tab algn="l" pos="0"/>
               </a:tabLst>
             </a:pPr>
-            <a:fld id="{7D13A75E-6F5A-4FB2-9FD1-ECFB6A2760DE}" type="slidenum">
+            <a:fld id="{DCA0C763-84E3-455D-8D9A-333748272849}" type="slidenum">
               <a:rPr b="0" lang="en" sz="1000" strike="noStrike" u="none">
                 <a:solidFill>
                   <a:schemeClr val="dk2"/>
@@ -9077,7 +9077,7 @@
                 <a:tab algn="l" pos="0"/>
               </a:tabLst>
             </a:pPr>
-            <a:fld id="{E5A2ACB2-48FA-4F10-BC6B-E9F47F2EEEDA}" type="slidenum">
+            <a:fld id="{2374854A-2F24-4208-83FC-8B14B520761A}" type="slidenum">
               <a:rPr b="0" lang="en" sz="1000" strike="noStrike" u="none">
                 <a:solidFill>
                   <a:schemeClr val="dk2"/>
@@ -9793,7 +9793,7 @@
                 <a:tab algn="l" pos="0"/>
               </a:tabLst>
             </a:pPr>
-            <a:fld id="{3F95C0C2-65DA-4BCD-8EFC-B866754A24BE}" type="slidenum">
+            <a:fld id="{52808CDC-B2FF-41B4-B73E-97A86EF88ECB}" type="slidenum">
               <a:rPr b="0" lang="en" sz="1000" strike="noStrike" u="none">
                 <a:solidFill>
                   <a:schemeClr val="dk2"/>
@@ -11057,7 +11057,7 @@
                 <a:tab algn="l" pos="0"/>
               </a:tabLst>
             </a:pPr>
-            <a:fld id="{9A0E1F7B-771A-4A06-91D3-01CC311376C1}" type="slidenum">
+            <a:fld id="{57358984-3647-4F5D-89FC-329071D42A7A}" type="slidenum">
               <a:rPr b="0" lang="en" sz="1000" strike="noStrike" u="none">
                 <a:solidFill>
                   <a:schemeClr val="dk2"/>
@@ -12869,7 +12869,7 @@
                 <a:tab algn="l" pos="0"/>
               </a:tabLst>
             </a:pPr>
-            <a:fld id="{BCB4865B-90ED-465E-B084-EDF03602CFCB}" type="slidenum">
+            <a:fld id="{3B183379-8DC3-4AEE-856B-FFE29175EFF7}" type="slidenum">
               <a:rPr b="0" lang="en" sz="1000" strike="noStrike" u="none">
                 <a:solidFill>
                   <a:schemeClr val="dk2"/>
@@ -12928,7 +12928,7 @@
         <p:txBody>
           <a:bodyPr/>
           <a:p>
-            <a:fld id="{E77CE31C-487B-419F-8EBB-A1F63CCC8997}" type="slidenum">
+            <a:fld id="{C13D3547-ACAF-4558-B178-E4F172C2F691}" type="slidenum">
               <a:t>&lt;#&gt;</a:t>
             </a:fld>
           </a:p>
@@ -12970,7 +12970,7 @@
         <p:txBody>
           <a:bodyPr/>
           <a:p>
-            <a:fld id="{30121A7A-D2D1-4AFC-9003-AB6DD6801B7E}" type="slidenum">
+            <a:fld id="{D6C338D1-E00C-414C-8258-F504A5547BDF}" type="slidenum">
               <a:t>&lt;#&gt;</a:t>
             </a:fld>
           </a:p>
@@ -13395,7 +13395,7 @@
                 <a:tab algn="l" pos="0"/>
               </a:tabLst>
             </a:pPr>
-            <a:fld id="{0F0E70E0-F4E7-4064-9016-3B9F75847A7B}" type="slidenum">
+            <a:fld id="{A8CF7F2A-1304-4FA9-8217-5600B21EF2E1}" type="slidenum">
               <a:rPr b="0" lang="en" sz="1000" strike="noStrike" u="none">
                 <a:solidFill>
                   <a:schemeClr val="dk2"/>
@@ -14111,7 +14111,7 @@
                 <a:tab algn="l" pos="0"/>
               </a:tabLst>
             </a:pPr>
-            <a:fld id="{2DFD1DFC-D816-4DC9-90A0-FE9838EC1459}" type="slidenum">
+            <a:fld id="{842474BF-BE8D-447D-96AF-8342C42F4D8F}" type="slidenum">
               <a:rPr b="0" lang="en" sz="1000" strike="noStrike" u="none">
                 <a:solidFill>
                   <a:schemeClr val="dk2"/>
@@ -14279,7 +14279,7 @@
                 <a:tab algn="l" pos="0"/>
               </a:tabLst>
             </a:pPr>
-            <a:fld id="{5811CF29-AB15-4526-8619-72C65D58AB40}" type="slidenum">
+            <a:fld id="{FF60B45A-0111-4D38-9A29-E0B625C650B5}" type="slidenum">
               <a:rPr b="0" lang="en" sz="1000" strike="noStrike" u="none">
                 <a:solidFill>
                   <a:schemeClr val="dk2"/>
@@ -14388,7 +14388,7 @@
                 <a:tab algn="l" pos="0"/>
               </a:tabLst>
             </a:pPr>
-            <a:fld id="{0B801CA3-AAF4-4FB0-8475-DA4AFE37078A}" type="slidenum">
+            <a:fld id="{480B9831-4E97-4FE7-81DC-24FBC7C0D842}" type="slidenum">
               <a:rPr b="0" lang="en" sz="1000" strike="noStrike" u="none">
                 <a:solidFill>
                   <a:schemeClr val="dk2"/>
@@ -15378,7 +15378,7 @@
                 <a:tab algn="l" pos="0"/>
               </a:tabLst>
             </a:pPr>
-            <a:fld id="{20F58F78-E017-411F-8BF5-0F85C55496B9}" type="slidenum">
+            <a:fld id="{873961C3-67A3-484B-94A0-FAF4CEF6261D}" type="slidenum">
               <a:rPr b="0" lang="en" sz="1000" strike="noStrike" u="none">
                 <a:solidFill>
                   <a:schemeClr val="dk2"/>
@@ -16368,7 +16368,7 @@
                 <a:tab algn="l" pos="0"/>
               </a:tabLst>
             </a:pPr>
-            <a:fld id="{5D9BFFFE-185A-4C27-BAEE-0742488D95DD}" type="slidenum">
+            <a:fld id="{EFCCCADF-39F9-4CA5-915C-A638B847E43D}" type="slidenum">
               <a:rPr b="0" lang="en" sz="1000" strike="noStrike" u="none">
                 <a:solidFill>
                   <a:schemeClr val="dk2"/>
@@ -17358,7 +17358,7 @@
                 <a:tab algn="l" pos="0"/>
               </a:tabLst>
             </a:pPr>
-            <a:fld id="{D83BE72C-24F3-49BE-9E12-666AFCF61CF8}" type="slidenum">
+            <a:fld id="{D94B2CCE-8437-47EA-9A00-239F43FC2F35}" type="slidenum">
               <a:rPr b="0" lang="en" sz="1000" strike="noStrike" u="none">
                 <a:solidFill>
                   <a:schemeClr val="dk2"/>
@@ -17541,7 +17541,7 @@
                 <a:tab algn="l" pos="0"/>
               </a:tabLst>
             </a:pPr>
-            <a:fld id="{B3BF30EE-646E-4903-8BF8-2D00C1DFC6DF}" type="slidenum">
+            <a:fld id="{08E68EEC-BE64-4CCC-AE7D-068DED20C5EF}" type="slidenum">
               <a:rPr b="0" lang="en" sz="1000" strike="noStrike" u="none">
                 <a:solidFill>
                   <a:schemeClr val="dk2"/>
@@ -17960,7 +17960,7 @@
                 <a:tab algn="l" pos="0"/>
               </a:tabLst>
             </a:pPr>
-            <a:fld id="{DF986AB7-BD66-4DEB-BECC-54B98C078877}" type="slidenum">
+            <a:fld id="{8C807E6D-C992-4517-AE7F-D42B874FA4F3}" type="slidenum">
               <a:rPr b="0" lang="en" sz="1000" strike="noStrike" u="none">
                 <a:solidFill>
                   <a:schemeClr val="dk2"/>
@@ -18472,7 +18472,7 @@
                 <a:tab algn="l" pos="0"/>
               </a:tabLst>
             </a:pPr>
-            <a:fld id="{94C5AF41-9A08-4687-B85F-1C08E4D8AE71}" type="datetime5">
+            <a:fld id="{AD8F44C4-5754-4CC6-9D23-CEF042B34FBE}" type="datetime5">
               <a:rPr b="0" lang="en" sz="1200" strike="noStrike" u="none">
                 <a:solidFill>
                   <a:srgbClr val="2a2a2a"/>

</xml_diff>